<commit_message>
docs(fieldcheck): 슬라이드 17의 영역 표시를 camera_roi.json 실좌표로 교체
설명용 근사 위치가 아니라 점검 장비에 실제 지정된 판정 좌표
(target 108,94,1063x182 / reference 46,142,106x543 — 1280x720)를
슬라이드 좌표로 환산해 그대로 표시.

Co-Authored-By: Claude Fable 5 <noreply@anthropic.com>
Claude-Session: https://claude.ai/code/session_01STxgiiyWdouXcYyEii3FdS
</commit_message>
<xml_diff>
--- a/thinqreal/fieldcheck/FieldCheck_진행보고_20260805.pptx
+++ b/thinqreal/fieldcheck/FieldCheck_진행보고_20260805.pptx
@@ -10423,8 +10423,8 @@
         </p:nvSpPr>
         <p:spPr>
           <a:xfrm>
-            <a:off x="1060704" y="2112264"/>
-            <a:ext cx="1892808" cy="210312"/>
+            <a:off x="868680" y="1892808"/>
+            <a:ext cx="2240280" cy="384048"/>
           </a:xfrm>
           <a:prstGeom prst="rect">
             <a:avLst/>
@@ -10450,8 +10450,8 @@
         </p:nvSpPr>
         <p:spPr>
           <a:xfrm>
-            <a:off x="2999232" y="2322576"/>
-            <a:ext cx="292608" cy="548640"/>
+            <a:off x="740664" y="1993392"/>
+            <a:ext cx="219456" cy="1143000"/>
           </a:xfrm>
           <a:prstGeom prst="rect">
             <a:avLst/>
@@ -10477,8 +10477,8 @@
         </p:nvSpPr>
         <p:spPr>
           <a:xfrm>
-            <a:off x="3941064" y="2112264"/>
-            <a:ext cx="1892808" cy="210312"/>
+            <a:off x="3749040" y="1892808"/>
+            <a:ext cx="2240280" cy="384048"/>
           </a:xfrm>
           <a:prstGeom prst="rect">
             <a:avLst/>
@@ -10504,8 +10504,8 @@
         </p:nvSpPr>
         <p:spPr>
           <a:xfrm>
-            <a:off x="5879592" y="2322576"/>
-            <a:ext cx="292608" cy="548640"/>
+            <a:off x="3621024" y="1993392"/>
+            <a:ext cx="219456" cy="1143000"/>
           </a:xfrm>
           <a:prstGeom prst="rect">
             <a:avLst/>

</xml_diff>